<commit_message>
Added notes on meeting, as well as frida hook and personal tutorial to repo
</commit_message>
<xml_diff>
--- a/dev_documents/meetings/meeting_07/meeting_07.pptx
+++ b/dev_documents/meetings/meeting_07/meeting_07.pptx
@@ -8,21 +8,23 @@
     <p:sldId id="256" r:id="rId2"/>
     <p:sldId id="258" r:id="rId3"/>
     <p:sldId id="259" r:id="rId4"/>
-    <p:sldId id="260" r:id="rId5"/>
-    <p:sldId id="265" r:id="rId6"/>
-    <p:sldId id="261" r:id="rId7"/>
-    <p:sldId id="264" r:id="rId8"/>
-    <p:sldId id="263" r:id="rId9"/>
-    <p:sldId id="262" r:id="rId10"/>
-    <p:sldId id="266" r:id="rId11"/>
-    <p:sldId id="267" r:id="rId12"/>
-    <p:sldId id="268" r:id="rId13"/>
-    <p:sldId id="269" r:id="rId14"/>
-    <p:sldId id="270" r:id="rId15"/>
-    <p:sldId id="271" r:id="rId16"/>
-    <p:sldId id="272" r:id="rId17"/>
-    <p:sldId id="273" r:id="rId18"/>
-    <p:sldId id="274" r:id="rId19"/>
+    <p:sldId id="275" r:id="rId5"/>
+    <p:sldId id="260" r:id="rId6"/>
+    <p:sldId id="265" r:id="rId7"/>
+    <p:sldId id="261" r:id="rId8"/>
+    <p:sldId id="264" r:id="rId9"/>
+    <p:sldId id="263" r:id="rId10"/>
+    <p:sldId id="262" r:id="rId11"/>
+    <p:sldId id="266" r:id="rId12"/>
+    <p:sldId id="267" r:id="rId13"/>
+    <p:sldId id="268" r:id="rId14"/>
+    <p:sldId id="269" r:id="rId15"/>
+    <p:sldId id="270" r:id="rId16"/>
+    <p:sldId id="271" r:id="rId17"/>
+    <p:sldId id="272" r:id="rId18"/>
+    <p:sldId id="273" r:id="rId19"/>
+    <p:sldId id="276" r:id="rId20"/>
+    <p:sldId id="274" r:id="rId21"/>
   </p:sldIdLst>
   <p:sldSz cx="12192000" cy="6858000"/>
   <p:notesSz cx="6858000" cy="9144000"/>
@@ -121,6 +123,11 @@
       </a:defRPr>
     </a:lvl9pPr>
   </p:defaultTextStyle>
+  <p:extLst>
+    <p:ext uri="{EFAFB233-063F-42B5-8137-9DF3F51BA10A}">
+      <p15:sldGuideLst xmlns:p15="http://schemas.microsoft.com/office/powerpoint/2012/main"/>
+    </p:ext>
+  </p:extLst>
 </p:presentation>
 </file>
 
@@ -273,7 +280,7 @@
           <a:p>
             <a:fld id="{9AB30458-6B80-4991-80A5-4D93347D5E6D}" type="datetimeFigureOut">
               <a:rPr lang="de-CH" smtClean="0"/>
-              <a:t>17.12.2025</a:t>
+              <a:t>19.12.2025</a:t>
             </a:fld>
             <a:endParaRPr lang="de-CH"/>
           </a:p>
@@ -473,7 +480,7 @@
           <a:p>
             <a:fld id="{9AB30458-6B80-4991-80A5-4D93347D5E6D}" type="datetimeFigureOut">
               <a:rPr lang="de-CH" smtClean="0"/>
-              <a:t>17.12.2025</a:t>
+              <a:t>19.12.2025</a:t>
             </a:fld>
             <a:endParaRPr lang="de-CH"/>
           </a:p>
@@ -683,7 +690,7 @@
           <a:p>
             <a:fld id="{9AB30458-6B80-4991-80A5-4D93347D5E6D}" type="datetimeFigureOut">
               <a:rPr lang="de-CH" smtClean="0"/>
-              <a:t>17.12.2025</a:t>
+              <a:t>19.12.2025</a:t>
             </a:fld>
             <a:endParaRPr lang="de-CH"/>
           </a:p>
@@ -883,7 +890,7 @@
           <a:p>
             <a:fld id="{9AB30458-6B80-4991-80A5-4D93347D5E6D}" type="datetimeFigureOut">
               <a:rPr lang="de-CH" smtClean="0"/>
-              <a:t>17.12.2025</a:t>
+              <a:t>19.12.2025</a:t>
             </a:fld>
             <a:endParaRPr lang="de-CH"/>
           </a:p>
@@ -1159,7 +1166,7 @@
           <a:p>
             <a:fld id="{9AB30458-6B80-4991-80A5-4D93347D5E6D}" type="datetimeFigureOut">
               <a:rPr lang="de-CH" smtClean="0"/>
-              <a:t>17.12.2025</a:t>
+              <a:t>19.12.2025</a:t>
             </a:fld>
             <a:endParaRPr lang="de-CH"/>
           </a:p>
@@ -1427,7 +1434,7 @@
           <a:p>
             <a:fld id="{9AB30458-6B80-4991-80A5-4D93347D5E6D}" type="datetimeFigureOut">
               <a:rPr lang="de-CH" smtClean="0"/>
-              <a:t>17.12.2025</a:t>
+              <a:t>19.12.2025</a:t>
             </a:fld>
             <a:endParaRPr lang="de-CH"/>
           </a:p>
@@ -1842,7 +1849,7 @@
           <a:p>
             <a:fld id="{9AB30458-6B80-4991-80A5-4D93347D5E6D}" type="datetimeFigureOut">
               <a:rPr lang="de-CH" smtClean="0"/>
-              <a:t>17.12.2025</a:t>
+              <a:t>19.12.2025</a:t>
             </a:fld>
             <a:endParaRPr lang="de-CH"/>
           </a:p>
@@ -1984,7 +1991,7 @@
           <a:p>
             <a:fld id="{9AB30458-6B80-4991-80A5-4D93347D5E6D}" type="datetimeFigureOut">
               <a:rPr lang="de-CH" smtClean="0"/>
-              <a:t>17.12.2025</a:t>
+              <a:t>19.12.2025</a:t>
             </a:fld>
             <a:endParaRPr lang="de-CH"/>
           </a:p>
@@ -2097,7 +2104,7 @@
           <a:p>
             <a:fld id="{9AB30458-6B80-4991-80A5-4D93347D5E6D}" type="datetimeFigureOut">
               <a:rPr lang="de-CH" smtClean="0"/>
-              <a:t>17.12.2025</a:t>
+              <a:t>19.12.2025</a:t>
             </a:fld>
             <a:endParaRPr lang="de-CH"/>
           </a:p>
@@ -2410,7 +2417,7 @@
           <a:p>
             <a:fld id="{9AB30458-6B80-4991-80A5-4D93347D5E6D}" type="datetimeFigureOut">
               <a:rPr lang="de-CH" smtClean="0"/>
-              <a:t>17.12.2025</a:t>
+              <a:t>19.12.2025</a:t>
             </a:fld>
             <a:endParaRPr lang="de-CH"/>
           </a:p>
@@ -2699,7 +2706,7 @@
           <a:p>
             <a:fld id="{9AB30458-6B80-4991-80A5-4D93347D5E6D}" type="datetimeFigureOut">
               <a:rPr lang="de-CH" smtClean="0"/>
-              <a:t>17.12.2025</a:t>
+              <a:t>19.12.2025</a:t>
             </a:fld>
             <a:endParaRPr lang="de-CH"/>
           </a:p>
@@ -2942,7 +2949,7 @@
           <a:p>
             <a:fld id="{9AB30458-6B80-4991-80A5-4D93347D5E6D}" type="datetimeFigureOut">
               <a:rPr lang="de-CH" smtClean="0"/>
-              <a:t>17.12.2025</a:t>
+              <a:t>19.12.2025</a:t>
             </a:fld>
             <a:endParaRPr lang="de-CH"/>
           </a:p>
@@ -3440,6 +3447,136 @@
         <p:cNvPr id="1" name="">
           <a:extLst>
             <a:ext uri="{FF2B5EF4-FFF2-40B4-BE49-F238E27FC236}">
+              <a16:creationId xmlns:a16="http://schemas.microsoft.com/office/drawing/2014/main" id="{9F1D8A09-B85F-92EB-54E3-667A6F6675B4}"/>
+            </a:ext>
+          </a:extLst>
+        </p:cNvPr>
+        <p:cNvGrpSpPr/>
+        <p:nvPr/>
+      </p:nvGrpSpPr>
+      <p:grpSpPr>
+        <a:xfrm>
+          <a:off x="0" y="0"/>
+          <a:ext cx="0" cy="0"/>
+          <a:chOff x="0" y="0"/>
+          <a:chExt cx="0" cy="0"/>
+        </a:xfrm>
+      </p:grpSpPr>
+      <p:sp>
+        <p:nvSpPr>
+          <p:cNvPr id="2" name="Titel 1">
+            <a:extLst>
+              <a:ext uri="{FF2B5EF4-FFF2-40B4-BE49-F238E27FC236}">
+                <a16:creationId xmlns:a16="http://schemas.microsoft.com/office/drawing/2014/main" id="{48FC1805-E445-7E86-FA1D-BA9D4EB70BC7}"/>
+              </a:ext>
+            </a:extLst>
+          </p:cNvPr>
+          <p:cNvSpPr>
+            <a:spLocks noGrp="1"/>
+          </p:cNvSpPr>
+          <p:nvPr>
+            <p:ph type="title"/>
+          </p:nvPr>
+        </p:nvSpPr>
+        <p:spPr/>
+        <p:txBody>
+          <a:bodyPr/>
+          <a:lstStyle/>
+          <a:p>
+            <a:r>
+              <a:rPr lang="de-DE" dirty="0"/>
+              <a:t>Neue Kategorie</a:t>
+            </a:r>
+            <a:endParaRPr lang="de-CH" dirty="0"/>
+          </a:p>
+        </p:txBody>
+      </p:sp>
+      <p:sp>
+        <p:nvSpPr>
+          <p:cNvPr id="3" name="Inhaltsplatzhalter 2">
+            <a:extLst>
+              <a:ext uri="{FF2B5EF4-FFF2-40B4-BE49-F238E27FC236}">
+                <a16:creationId xmlns:a16="http://schemas.microsoft.com/office/drawing/2014/main" id="{DF2E7619-F740-4A78-5CDE-E1D1ADCEEBBB}"/>
+              </a:ext>
+            </a:extLst>
+          </p:cNvPr>
+          <p:cNvSpPr>
+            <a:spLocks noGrp="1"/>
+          </p:cNvSpPr>
+          <p:nvPr>
+            <p:ph idx="1"/>
+          </p:nvPr>
+        </p:nvSpPr>
+        <p:spPr/>
+        <p:txBody>
+          <a:bodyPr/>
+          <a:lstStyle/>
+          <a:p>
+            <a:endParaRPr lang="de-DE" dirty="0"/>
+          </a:p>
+          <a:p>
+            <a:r>
+              <a:rPr lang="de-CH" dirty="0"/>
+              <a:t>Neue </a:t>
+            </a:r>
+            <a:r>
+              <a:rPr lang="de-CH" dirty="0" err="1"/>
+              <a:t>Vulnerabilities</a:t>
+            </a:r>
+            <a:r>
+              <a:rPr lang="de-CH" dirty="0"/>
+              <a:t> (</a:t>
+            </a:r>
+            <a:r>
+              <a:rPr lang="de-CH" dirty="0" err="1"/>
+              <a:t>Platform</a:t>
+            </a:r>
+            <a:r>
+              <a:rPr lang="de-CH" dirty="0"/>
+              <a:t>):</a:t>
+            </a:r>
+          </a:p>
+          <a:p>
+            <a:r>
+              <a:rPr lang="de-CH" dirty="0"/>
+              <a:t>Maswe_0055</a:t>
+            </a:r>
+          </a:p>
+          <a:p>
+            <a:r>
+              <a:rPr lang="de-CH" dirty="0"/>
+              <a:t>Maswe_0053</a:t>
+            </a:r>
+          </a:p>
+          <a:p>
+            <a:r>
+              <a:rPr lang="de-CH" dirty="0"/>
+              <a:t>Maswe_0067</a:t>
+            </a:r>
+          </a:p>
+        </p:txBody>
+      </p:sp>
+    </p:spTree>
+    <p:extLst>
+      <p:ext uri="{BB962C8B-B14F-4D97-AF65-F5344CB8AC3E}">
+        <p14:creationId xmlns:p14="http://schemas.microsoft.com/office/powerpoint/2010/main" val="2095325492"/>
+      </p:ext>
+    </p:extLst>
+  </p:cSld>
+  <p:clrMapOvr>
+    <a:masterClrMapping/>
+  </p:clrMapOvr>
+</p:sld>
+</file>
+
+<file path=ppt/slides/slide11.xml><?xml version="1.0" encoding="utf-8"?>
+<p:sld xmlns:a="http://schemas.openxmlformats.org/drawingml/2006/main" xmlns:r="http://schemas.openxmlformats.org/officeDocument/2006/relationships" xmlns:p="http://schemas.openxmlformats.org/presentationml/2006/main">
+  <p:cSld>
+    <p:spTree>
+      <p:nvGrpSpPr>
+        <p:cNvPr id="1" name="">
+          <a:extLst>
+            <a:ext uri="{FF2B5EF4-FFF2-40B4-BE49-F238E27FC236}">
               <a16:creationId xmlns:a16="http://schemas.microsoft.com/office/drawing/2014/main" id="{84FA587F-F81C-B63F-8C74-5379DA521DF1}"/>
             </a:ext>
           </a:extLst>
@@ -3595,7 +3732,7 @@
 </p:sld>
 </file>
 
-<file path=ppt/slides/slide11.xml><?xml version="1.0" encoding="utf-8"?>
+<file path=ppt/slides/slide12.xml><?xml version="1.0" encoding="utf-8"?>
 <p:sld xmlns:a="http://schemas.openxmlformats.org/drawingml/2006/main" xmlns:r="http://schemas.openxmlformats.org/officeDocument/2006/relationships" xmlns:p="http://schemas.openxmlformats.org/presentationml/2006/main">
   <p:cSld>
     <p:spTree>
@@ -3706,7 +3843,7 @@
 </p:sld>
 </file>
 
-<file path=ppt/slides/slide12.xml><?xml version="1.0" encoding="utf-8"?>
+<file path=ppt/slides/slide13.xml><?xml version="1.0" encoding="utf-8"?>
 <p:sld xmlns:a="http://schemas.openxmlformats.org/drawingml/2006/main" xmlns:r="http://schemas.openxmlformats.org/officeDocument/2006/relationships" xmlns:p="http://schemas.openxmlformats.org/presentationml/2006/main">
   <p:cSld>
     <p:spTree>
@@ -3813,7 +3950,7 @@
 </p:sld>
 </file>
 
-<file path=ppt/slides/slide13.xml><?xml version="1.0" encoding="utf-8"?>
+<file path=ppt/slides/slide14.xml><?xml version="1.0" encoding="utf-8"?>
 <p:sld xmlns:a="http://schemas.openxmlformats.org/drawingml/2006/main" xmlns:r="http://schemas.openxmlformats.org/officeDocument/2006/relationships" xmlns:p="http://schemas.openxmlformats.org/presentationml/2006/main">
   <p:cSld>
     <p:spTree>
@@ -3920,7 +4057,7 @@
 </p:sld>
 </file>
 
-<file path=ppt/slides/slide14.xml><?xml version="1.0" encoding="utf-8"?>
+<file path=ppt/slides/slide15.xml><?xml version="1.0" encoding="utf-8"?>
 <p:sld xmlns:a="http://schemas.openxmlformats.org/drawingml/2006/main" xmlns:r="http://schemas.openxmlformats.org/officeDocument/2006/relationships" xmlns:p="http://schemas.openxmlformats.org/presentationml/2006/main">
   <p:cSld>
     <p:spTree>
@@ -4027,7 +4164,7 @@
 </p:sld>
 </file>
 
-<file path=ppt/slides/slide15.xml><?xml version="1.0" encoding="utf-8"?>
+<file path=ppt/slides/slide16.xml><?xml version="1.0" encoding="utf-8"?>
 <p:sld xmlns:a="http://schemas.openxmlformats.org/drawingml/2006/main" xmlns:r="http://schemas.openxmlformats.org/officeDocument/2006/relationships" xmlns:p="http://schemas.openxmlformats.org/presentationml/2006/main">
   <p:cSld>
     <p:spTree>
@@ -4170,7 +4307,7 @@
 </p:sld>
 </file>
 
-<file path=ppt/slides/slide16.xml><?xml version="1.0" encoding="utf-8"?>
+<file path=ppt/slides/slide17.xml><?xml version="1.0" encoding="utf-8"?>
 <p:sld xmlns:a="http://schemas.openxmlformats.org/drawingml/2006/main" xmlns:r="http://schemas.openxmlformats.org/officeDocument/2006/relationships" xmlns:p="http://schemas.openxmlformats.org/presentationml/2006/main">
   <p:cSld>
     <p:spTree>
@@ -4354,7 +4491,7 @@
 </p:sld>
 </file>
 
-<file path=ppt/slides/slide17.xml><?xml version="1.0" encoding="utf-8"?>
+<file path=ppt/slides/slide18.xml><?xml version="1.0" encoding="utf-8"?>
 <p:sld xmlns:a="http://schemas.openxmlformats.org/drawingml/2006/main" xmlns:r="http://schemas.openxmlformats.org/officeDocument/2006/relationships" xmlns:p="http://schemas.openxmlformats.org/presentationml/2006/main">
   <p:cSld>
     <p:spTree>
@@ -4493,7 +4630,7 @@
 </p:sld>
 </file>
 
-<file path=ppt/slides/slide18.xml><?xml version="1.0" encoding="utf-8"?>
+<file path=ppt/slides/slide19.xml><?xml version="1.0" encoding="utf-8"?>
 <p:sld xmlns:a="http://schemas.openxmlformats.org/drawingml/2006/main" xmlns:r="http://schemas.openxmlformats.org/officeDocument/2006/relationships" xmlns:p="http://schemas.openxmlformats.org/presentationml/2006/main">
   <p:cSld>
     <p:spTree>
@@ -4501,7 +4638,7 @@
         <p:cNvPr id="1" name="">
           <a:extLst>
             <a:ext uri="{FF2B5EF4-FFF2-40B4-BE49-F238E27FC236}">
-              <a16:creationId xmlns:a16="http://schemas.microsoft.com/office/drawing/2014/main" id="{80C58B5D-7EDF-BD44-2A19-717DD1EBEF17}"/>
+              <a16:creationId xmlns:a16="http://schemas.microsoft.com/office/drawing/2014/main" id="{C1346548-E9A4-ACA1-57E0-B72545C77253}"/>
             </a:ext>
           </a:extLst>
         </p:cNvPr>
@@ -4521,7 +4658,7 @@
           <p:cNvPr id="2" name="Titel 1">
             <a:extLst>
               <a:ext uri="{FF2B5EF4-FFF2-40B4-BE49-F238E27FC236}">
-                <a16:creationId xmlns:a16="http://schemas.microsoft.com/office/drawing/2014/main" id="{29A63BAA-0360-63A7-F0F0-C867008946FC}"/>
+                <a16:creationId xmlns:a16="http://schemas.microsoft.com/office/drawing/2014/main" id="{FBB9E0FF-F12E-15C5-D851-4660810D878C}"/>
               </a:ext>
             </a:extLst>
           </p:cNvPr>
@@ -4538,8 +4675,12 @@
           <a:lstStyle/>
           <a:p>
             <a:r>
+              <a:rPr lang="de-DE" dirty="0" err="1"/>
+              <a:t>Related</a:t>
+            </a:r>
+            <a:r>
               <a:rPr lang="de-DE" dirty="0"/>
-              <a:t>Nächste Schritte</a:t>
+              <a:t> Work nachbessern</a:t>
             </a:r>
             <a:endParaRPr lang="de-CH" dirty="0"/>
           </a:p>
@@ -4550,7 +4691,7 @@
           <p:cNvPr id="3" name="Inhaltsplatzhalter 4">
             <a:extLst>
               <a:ext uri="{FF2B5EF4-FFF2-40B4-BE49-F238E27FC236}">
-                <a16:creationId xmlns:a16="http://schemas.microsoft.com/office/drawing/2014/main" id="{BAEF579E-5120-6CD3-BAAA-A9EE1EAAC70C}"/>
+                <a16:creationId xmlns:a16="http://schemas.microsoft.com/office/drawing/2014/main" id="{F7C63426-6D98-25A1-0278-CF59C75D1751}"/>
               </a:ext>
             </a:extLst>
           </p:cNvPr>
@@ -4572,79 +4713,65 @@
           <a:lstStyle/>
           <a:p>
             <a:r>
+              <a:rPr lang="de-DE" dirty="0" err="1"/>
+              <a:t>Pg</a:t>
+            </a:r>
+            <a:r>
               <a:rPr lang="de-DE" dirty="0"/>
-              <a:t>Noch 12 Tage (mit Weihnachten, Neujahr </a:t>
-            </a:r>
-            <a:r>
-              <a:rPr lang="de-DE" dirty="0" err="1"/>
-              <a:t>etc</a:t>
-            </a:r>
-            <a:r>
-              <a:rPr lang="de-DE" dirty="0"/>
-              <a:t>)</a:t>
-            </a:r>
-          </a:p>
-          <a:p>
-            <a:r>
-              <a:rPr lang="de-DE" dirty="0"/>
-              <a:t>App fertig cleanen</a:t>
-            </a:r>
-          </a:p>
-          <a:p>
-            <a:r>
-              <a:rPr lang="de-DE" dirty="0"/>
-              <a:t>„</a:t>
-            </a:r>
-            <a:r>
-              <a:rPr lang="de-DE" dirty="0" err="1"/>
-              <a:t>How</a:t>
-            </a:r>
-            <a:r>
-              <a:rPr lang="de-DE" dirty="0"/>
-              <a:t> </a:t>
-            </a:r>
-            <a:r>
-              <a:rPr lang="de-DE" dirty="0" err="1"/>
-              <a:t>to</a:t>
-            </a:r>
-            <a:r>
-              <a:rPr lang="de-DE" dirty="0"/>
-              <a:t> </a:t>
-            </a:r>
-            <a:r>
-              <a:rPr lang="de-DE" dirty="0" err="1"/>
-              <a:t>contribute</a:t>
-            </a:r>
-            <a:r>
-              <a:rPr lang="de-DE" dirty="0"/>
-              <a:t>“?</a:t>
-            </a:r>
-          </a:p>
-          <a:p>
-            <a:r>
-              <a:rPr lang="de-DE" dirty="0" err="1"/>
-              <a:t>Vulnerability</a:t>
-            </a:r>
-            <a:r>
-              <a:rPr lang="de-DE" dirty="0"/>
-              <a:t> </a:t>
-            </a:r>
-            <a:r>
-              <a:rPr lang="de-DE" dirty="0" err="1"/>
-              <a:t>README‘s</a:t>
-            </a:r>
-            <a:r>
-              <a:rPr lang="de-DE" dirty="0"/>
-              <a:t> fertig ausbessern</a:t>
-            </a:r>
-          </a:p>
-          <a:p>
-            <a:r>
-              <a:rPr lang="de-DE" dirty="0"/>
-              <a:t>Was sind deine Erwartungen?</a:t>
-            </a:r>
-          </a:p>
-          <a:p>
+              <a:t> 14 „</a:t>
+            </a:r>
+            <a:r>
+              <a:rPr lang="de-CH" dirty="0"/>
+              <a:t>This </a:t>
+            </a:r>
+            <a:r>
+              <a:rPr lang="de-CH" dirty="0" err="1"/>
+              <a:t>left</a:t>
+            </a:r>
+            <a:r>
+              <a:rPr lang="de-CH" dirty="0"/>
+              <a:t> 15 </a:t>
+            </a:r>
+            <a:r>
+              <a:rPr lang="de-CH" dirty="0" err="1"/>
+              <a:t>papers</a:t>
+            </a:r>
+            <a:r>
+              <a:rPr lang="de-CH" dirty="0"/>
+              <a:t>,….» hier alle 15 References [][][][]… angeben?</a:t>
+            </a:r>
+          </a:p>
+          <a:p>
+            <a:r>
+              <a:rPr lang="de-CH" dirty="0" err="1"/>
+              <a:t>Pg</a:t>
+            </a:r>
+            <a:r>
+              <a:rPr lang="de-CH" dirty="0"/>
+              <a:t> 18 «</a:t>
+            </a:r>
+            <a:r>
+              <a:rPr lang="de-CH" dirty="0" err="1"/>
+              <a:t>iOs</a:t>
+            </a:r>
+            <a:r>
+              <a:rPr lang="de-CH" dirty="0"/>
+              <a:t>» als Begriff vermeiden?</a:t>
+            </a:r>
+          </a:p>
+          <a:p>
+            <a:r>
+              <a:rPr lang="de-CH" dirty="0" err="1"/>
+              <a:t>Pg</a:t>
+            </a:r>
+            <a:r>
+              <a:rPr lang="de-CH" dirty="0"/>
+              <a:t> 10 «</a:t>
+            </a:r>
+            <a:r>
+              <a:rPr lang="en-US" dirty="0"/>
+              <a:t>Since these apps are meant by OWASP to be educational,..”</a:t>
+            </a:r>
             <a:endParaRPr lang="de-CH" dirty="0"/>
           </a:p>
         </p:txBody>
@@ -4652,7 +4779,7 @@
     </p:spTree>
     <p:extLst>
       <p:ext uri="{BB962C8B-B14F-4D97-AF65-F5344CB8AC3E}">
-        <p14:creationId xmlns:p14="http://schemas.microsoft.com/office/powerpoint/2010/main" val="2488698096"/>
+        <p14:creationId xmlns:p14="http://schemas.microsoft.com/office/powerpoint/2010/main" val="3134162494"/>
       </p:ext>
     </p:extLst>
   </p:cSld>
@@ -4785,6 +4912,175 @@
     <p:extLst>
       <p:ext uri="{BB962C8B-B14F-4D97-AF65-F5344CB8AC3E}">
         <p14:creationId xmlns:p14="http://schemas.microsoft.com/office/powerpoint/2010/main" val="4120726205"/>
+      </p:ext>
+    </p:extLst>
+  </p:cSld>
+  <p:clrMapOvr>
+    <a:masterClrMapping/>
+  </p:clrMapOvr>
+</p:sld>
+</file>
+
+<file path=ppt/slides/slide20.xml><?xml version="1.0" encoding="utf-8"?>
+<p:sld xmlns:a="http://schemas.openxmlformats.org/drawingml/2006/main" xmlns:r="http://schemas.openxmlformats.org/officeDocument/2006/relationships" xmlns:p="http://schemas.openxmlformats.org/presentationml/2006/main">
+  <p:cSld>
+    <p:spTree>
+      <p:nvGrpSpPr>
+        <p:cNvPr id="1" name="">
+          <a:extLst>
+            <a:ext uri="{FF2B5EF4-FFF2-40B4-BE49-F238E27FC236}">
+              <a16:creationId xmlns:a16="http://schemas.microsoft.com/office/drawing/2014/main" id="{80C58B5D-7EDF-BD44-2A19-717DD1EBEF17}"/>
+            </a:ext>
+          </a:extLst>
+        </p:cNvPr>
+        <p:cNvGrpSpPr/>
+        <p:nvPr/>
+      </p:nvGrpSpPr>
+      <p:grpSpPr>
+        <a:xfrm>
+          <a:off x="0" y="0"/>
+          <a:ext cx="0" cy="0"/>
+          <a:chOff x="0" y="0"/>
+          <a:chExt cx="0" cy="0"/>
+        </a:xfrm>
+      </p:grpSpPr>
+      <p:sp>
+        <p:nvSpPr>
+          <p:cNvPr id="2" name="Titel 1">
+            <a:extLst>
+              <a:ext uri="{FF2B5EF4-FFF2-40B4-BE49-F238E27FC236}">
+                <a16:creationId xmlns:a16="http://schemas.microsoft.com/office/drawing/2014/main" id="{29A63BAA-0360-63A7-F0F0-C867008946FC}"/>
+              </a:ext>
+            </a:extLst>
+          </p:cNvPr>
+          <p:cNvSpPr>
+            <a:spLocks noGrp="1"/>
+          </p:cNvSpPr>
+          <p:nvPr>
+            <p:ph type="title"/>
+          </p:nvPr>
+        </p:nvSpPr>
+        <p:spPr/>
+        <p:txBody>
+          <a:bodyPr/>
+          <a:lstStyle/>
+          <a:p>
+            <a:r>
+              <a:rPr lang="de-DE" dirty="0"/>
+              <a:t>Nächste Schritte</a:t>
+            </a:r>
+            <a:endParaRPr lang="de-CH" dirty="0"/>
+          </a:p>
+        </p:txBody>
+      </p:sp>
+      <p:sp>
+        <p:nvSpPr>
+          <p:cNvPr id="3" name="Inhaltsplatzhalter 4">
+            <a:extLst>
+              <a:ext uri="{FF2B5EF4-FFF2-40B4-BE49-F238E27FC236}">
+                <a16:creationId xmlns:a16="http://schemas.microsoft.com/office/drawing/2014/main" id="{BAEF579E-5120-6CD3-BAAA-A9EE1EAAC70C}"/>
+              </a:ext>
+            </a:extLst>
+          </p:cNvPr>
+          <p:cNvSpPr>
+            <a:spLocks noGrp="1"/>
+          </p:cNvSpPr>
+          <p:nvPr>
+            <p:ph idx="1"/>
+          </p:nvPr>
+        </p:nvSpPr>
+        <p:spPr>
+          <a:xfrm>
+            <a:off x="838200" y="1825625"/>
+            <a:ext cx="10515600" cy="4351338"/>
+          </a:xfrm>
+        </p:spPr>
+        <p:txBody>
+          <a:bodyPr/>
+          <a:lstStyle/>
+          <a:p>
+            <a:r>
+              <a:rPr lang="de-DE" dirty="0"/>
+              <a:t>Noch 12 Tage (mit Weihnachten, Neujahr </a:t>
+            </a:r>
+            <a:r>
+              <a:rPr lang="de-DE" dirty="0" err="1"/>
+              <a:t>etc</a:t>
+            </a:r>
+            <a:r>
+              <a:rPr lang="de-DE" dirty="0"/>
+              <a:t>)</a:t>
+            </a:r>
+          </a:p>
+          <a:p>
+            <a:r>
+              <a:rPr lang="de-DE" dirty="0"/>
+              <a:t>Apps fertig cleanen (Code Standard)</a:t>
+            </a:r>
+          </a:p>
+          <a:p>
+            <a:r>
+              <a:rPr lang="de-DE" dirty="0"/>
+              <a:t>„</a:t>
+            </a:r>
+            <a:r>
+              <a:rPr lang="de-DE" dirty="0" err="1"/>
+              <a:t>How</a:t>
+            </a:r>
+            <a:r>
+              <a:rPr lang="de-DE" dirty="0"/>
+              <a:t> </a:t>
+            </a:r>
+            <a:r>
+              <a:rPr lang="de-DE" dirty="0" err="1"/>
+              <a:t>to</a:t>
+            </a:r>
+            <a:r>
+              <a:rPr lang="de-DE" dirty="0"/>
+              <a:t> </a:t>
+            </a:r>
+            <a:r>
+              <a:rPr lang="de-DE" dirty="0" err="1"/>
+              <a:t>contribute</a:t>
+            </a:r>
+            <a:r>
+              <a:rPr lang="de-DE" dirty="0"/>
+              <a:t>“?</a:t>
+            </a:r>
+          </a:p>
+          <a:p>
+            <a:r>
+              <a:rPr lang="de-DE" dirty="0" err="1"/>
+              <a:t>Vulnerability</a:t>
+            </a:r>
+            <a:r>
+              <a:rPr lang="de-DE" dirty="0"/>
+              <a:t> </a:t>
+            </a:r>
+            <a:r>
+              <a:rPr lang="de-DE" dirty="0" err="1"/>
+              <a:t>README‘s</a:t>
+            </a:r>
+            <a:r>
+              <a:rPr lang="de-DE" dirty="0"/>
+              <a:t> fertig ausbessern</a:t>
+            </a:r>
+          </a:p>
+          <a:p>
+            <a:r>
+              <a:rPr lang="de-DE" dirty="0"/>
+              <a:t>Was sind deine Erwartungen?</a:t>
+            </a:r>
+          </a:p>
+          <a:p>
+            <a:endParaRPr lang="de-CH" dirty="0"/>
+          </a:p>
+        </p:txBody>
+      </p:sp>
+    </p:spTree>
+    <p:extLst>
+      <p:ext uri="{BB962C8B-B14F-4D97-AF65-F5344CB8AC3E}">
+        <p14:creationId xmlns:p14="http://schemas.microsoft.com/office/powerpoint/2010/main" val="2488698096"/>
       </p:ext>
     </p:extLst>
   </p:cSld>
@@ -4877,7 +5173,7 @@
           <a:p>
             <a:r>
               <a:rPr lang="de-DE" dirty="0"/>
-              <a:t>Läuft eigentlich auf </a:t>
+              <a:t>Läuft auf </a:t>
             </a:r>
             <a:r>
               <a:rPr lang="de-DE" dirty="0" err="1"/>
@@ -4886,25 +5182,147 @@
             <a:r>
               <a:rPr lang="de-DE" dirty="0"/>
               <a:t> Device</a:t>
-            </a:r>
-          </a:p>
-          <a:p>
-            <a:r>
-              <a:rPr lang="de-DE" dirty="0"/>
-              <a:t>Gerät rooten noch Thema</a:t>
             </a:r>
           </a:p>
           <a:p>
             <a:pPr marL="0" indent="0">
               <a:buNone/>
             </a:pPr>
-            <a:r>
-              <a:rPr lang="de-DE" dirty="0"/>
-              <a:t>-&gt; https://gitlab.com/newbit/rootAVD</a:t>
-            </a:r>
-          </a:p>
-          <a:p>
             <a:endParaRPr lang="de-CH" dirty="0"/>
+          </a:p>
+        </p:txBody>
+      </p:sp>
+      <p:pic>
+        <p:nvPicPr>
+          <p:cNvPr id="5" name="Grafik 4">
+            <a:extLst>
+              <a:ext uri="{FF2B5EF4-FFF2-40B4-BE49-F238E27FC236}">
+                <a16:creationId xmlns:a16="http://schemas.microsoft.com/office/drawing/2014/main" id="{BB202C91-8BD7-BD6D-54E0-785EF02D9CA9}"/>
+              </a:ext>
+            </a:extLst>
+          </p:cNvPr>
+          <p:cNvPicPr>
+            <a:picLocks noChangeAspect="1"/>
+          </p:cNvPicPr>
+          <p:nvPr/>
+        </p:nvPicPr>
+        <p:blipFill>
+          <a:blip r:embed="rId2"/>
+          <a:stretch>
+            <a:fillRect/>
+          </a:stretch>
+        </p:blipFill>
+        <p:spPr>
+          <a:xfrm>
+            <a:off x="0" y="2956837"/>
+            <a:ext cx="12192000" cy="3697357"/>
+          </a:xfrm>
+          <a:prstGeom prst="rect">
+            <a:avLst/>
+          </a:prstGeom>
+        </p:spPr>
+      </p:pic>
+      <p:sp>
+        <p:nvSpPr>
+          <p:cNvPr id="6" name="Rechteck 5">
+            <a:extLst>
+              <a:ext uri="{FF2B5EF4-FFF2-40B4-BE49-F238E27FC236}">
+                <a16:creationId xmlns:a16="http://schemas.microsoft.com/office/drawing/2014/main" id="{BBEA39B3-732B-6E40-B827-F51E51E53146}"/>
+              </a:ext>
+            </a:extLst>
+          </p:cNvPr>
+          <p:cNvSpPr/>
+          <p:nvPr/>
+        </p:nvSpPr>
+        <p:spPr>
+          <a:xfrm>
+            <a:off x="4355690" y="5329084"/>
+            <a:ext cx="2812026" cy="265471"/>
+          </a:xfrm>
+          <a:prstGeom prst="rect">
+            <a:avLst/>
+          </a:prstGeom>
+          <a:noFill/>
+          <a:ln w="57150">
+            <a:solidFill>
+              <a:srgbClr val="FF0000"/>
+            </a:solidFill>
+          </a:ln>
+        </p:spPr>
+        <p:style>
+          <a:lnRef idx="2">
+            <a:schemeClr val="accent1">
+              <a:shade val="15000"/>
+            </a:schemeClr>
+          </a:lnRef>
+          <a:fillRef idx="1">
+            <a:schemeClr val="accent1"/>
+          </a:fillRef>
+          <a:effectRef idx="0">
+            <a:schemeClr val="accent1"/>
+          </a:effectRef>
+          <a:fontRef idx="minor">
+            <a:schemeClr val="lt1"/>
+          </a:fontRef>
+        </p:style>
+        <p:txBody>
+          <a:bodyPr rtlCol="0" anchor="ctr"/>
+          <a:lstStyle/>
+          <a:p>
+            <a:pPr algn="ctr"/>
+            <a:endParaRPr lang="de-CH"/>
+          </a:p>
+        </p:txBody>
+      </p:sp>
+      <p:sp>
+        <p:nvSpPr>
+          <p:cNvPr id="7" name="Rechteck 6">
+            <a:extLst>
+              <a:ext uri="{FF2B5EF4-FFF2-40B4-BE49-F238E27FC236}">
+                <a16:creationId xmlns:a16="http://schemas.microsoft.com/office/drawing/2014/main" id="{E0274D65-2D01-3571-15F6-352115668E0F}"/>
+              </a:ext>
+            </a:extLst>
+          </p:cNvPr>
+          <p:cNvSpPr/>
+          <p:nvPr/>
+        </p:nvSpPr>
+        <p:spPr>
+          <a:xfrm>
+            <a:off x="0" y="6046839"/>
+            <a:ext cx="12192000" cy="421328"/>
+          </a:xfrm>
+          <a:prstGeom prst="rect">
+            <a:avLst/>
+          </a:prstGeom>
+          <a:noFill/>
+          <a:ln w="57150">
+            <a:solidFill>
+              <a:srgbClr val="FF0000"/>
+            </a:solidFill>
+          </a:ln>
+        </p:spPr>
+        <p:style>
+          <a:lnRef idx="2">
+            <a:schemeClr val="accent1">
+              <a:shade val="15000"/>
+            </a:schemeClr>
+          </a:lnRef>
+          <a:fillRef idx="1">
+            <a:schemeClr val="accent1"/>
+          </a:fillRef>
+          <a:effectRef idx="0">
+            <a:schemeClr val="accent1"/>
+          </a:effectRef>
+          <a:fontRef idx="minor">
+            <a:schemeClr val="lt1"/>
+          </a:fontRef>
+        </p:style>
+        <p:txBody>
+          <a:bodyPr rtlCol="0" anchor="ctr"/>
+          <a:lstStyle/>
+          <a:p>
+            <a:pPr algn="ctr"/>
+            <a:endParaRPr lang="de-CH"/>
           </a:p>
         </p:txBody>
       </p:sp>
@@ -4922,6 +5340,119 @@
 </file>
 
 <file path=ppt/slides/slide4.xml><?xml version="1.0" encoding="utf-8"?>
+<p:sld xmlns:a="http://schemas.openxmlformats.org/drawingml/2006/main" xmlns:r="http://schemas.openxmlformats.org/officeDocument/2006/relationships" xmlns:p="http://schemas.openxmlformats.org/presentationml/2006/main">
+  <p:cSld>
+    <p:spTree>
+      <p:nvGrpSpPr>
+        <p:cNvPr id="1" name="">
+          <a:extLst>
+            <a:ext uri="{FF2B5EF4-FFF2-40B4-BE49-F238E27FC236}">
+              <a16:creationId xmlns:a16="http://schemas.microsoft.com/office/drawing/2014/main" id="{2A2C47C1-73C6-B1E6-0BC3-4CADADA8C36C}"/>
+            </a:ext>
+          </a:extLst>
+        </p:cNvPr>
+        <p:cNvGrpSpPr/>
+        <p:nvPr/>
+      </p:nvGrpSpPr>
+      <p:grpSpPr>
+        <a:xfrm>
+          <a:off x="0" y="0"/>
+          <a:ext cx="0" cy="0"/>
+          <a:chOff x="0" y="0"/>
+          <a:chExt cx="0" cy="0"/>
+        </a:xfrm>
+      </p:grpSpPr>
+      <p:sp>
+        <p:nvSpPr>
+          <p:cNvPr id="2" name="Titel 1">
+            <a:extLst>
+              <a:ext uri="{FF2B5EF4-FFF2-40B4-BE49-F238E27FC236}">
+                <a16:creationId xmlns:a16="http://schemas.microsoft.com/office/drawing/2014/main" id="{6D12BA75-F296-0E4D-04D5-836A608F0F2B}"/>
+              </a:ext>
+            </a:extLst>
+          </p:cNvPr>
+          <p:cNvSpPr>
+            <a:spLocks noGrp="1"/>
+          </p:cNvSpPr>
+          <p:nvPr>
+            <p:ph type="title"/>
+          </p:nvPr>
+        </p:nvSpPr>
+        <p:spPr/>
+        <p:txBody>
+          <a:bodyPr/>
+          <a:lstStyle/>
+          <a:p>
+            <a:r>
+              <a:rPr lang="de-DE" dirty="0"/>
+              <a:t>Frida </a:t>
+            </a:r>
+            <a:r>
+              <a:rPr lang="de-DE" dirty="0" err="1"/>
+              <a:t>Rooted</a:t>
+            </a:r>
+            <a:r>
+              <a:rPr lang="de-DE" dirty="0"/>
+              <a:t> Device</a:t>
+            </a:r>
+            <a:endParaRPr lang="de-CH" dirty="0"/>
+          </a:p>
+        </p:txBody>
+      </p:sp>
+      <p:sp>
+        <p:nvSpPr>
+          <p:cNvPr id="3" name="Inhaltsplatzhalter 2">
+            <a:extLst>
+              <a:ext uri="{FF2B5EF4-FFF2-40B4-BE49-F238E27FC236}">
+                <a16:creationId xmlns:a16="http://schemas.microsoft.com/office/drawing/2014/main" id="{55EB899A-578A-B189-0B06-F544A9F351D7}"/>
+              </a:ext>
+            </a:extLst>
+          </p:cNvPr>
+          <p:cNvSpPr>
+            <a:spLocks noGrp="1"/>
+          </p:cNvSpPr>
+          <p:nvPr>
+            <p:ph idx="1"/>
+          </p:nvPr>
+        </p:nvSpPr>
+        <p:spPr/>
+        <p:txBody>
+          <a:bodyPr/>
+          <a:lstStyle/>
+          <a:p>
+            <a:r>
+              <a:rPr lang="de-DE" dirty="0"/>
+              <a:t>Gerät rooten noch Thema</a:t>
+            </a:r>
+          </a:p>
+          <a:p>
+            <a:pPr marL="0" indent="0">
+              <a:buNone/>
+            </a:pPr>
+            <a:r>
+              <a:rPr lang="de-DE" dirty="0"/>
+              <a:t>-&gt; https://gitlab.com/newbit/rootAVD</a:t>
+            </a:r>
+          </a:p>
+          <a:p>
+            <a:endParaRPr lang="de-CH" dirty="0"/>
+          </a:p>
+        </p:txBody>
+      </p:sp>
+    </p:spTree>
+    <p:extLst>
+      <p:ext uri="{BB962C8B-B14F-4D97-AF65-F5344CB8AC3E}">
+        <p14:creationId xmlns:p14="http://schemas.microsoft.com/office/powerpoint/2010/main" val="4227728309"/>
+      </p:ext>
+    </p:extLst>
+  </p:cSld>
+  <p:clrMapOvr>
+    <a:masterClrMapping/>
+  </p:clrMapOvr>
+</p:sld>
+</file>
+
+<file path=ppt/slides/slide5.xml><?xml version="1.0" encoding="utf-8"?>
 <p:sld xmlns:a="http://schemas.openxmlformats.org/drawingml/2006/main" xmlns:r="http://schemas.openxmlformats.org/officeDocument/2006/relationships" xmlns:p="http://schemas.openxmlformats.org/presentationml/2006/main">
   <p:cSld>
     <p:spTree>
@@ -5017,7 +5548,7 @@
 </p:sld>
 </file>
 
-<file path=ppt/slides/slide5.xml><?xml version="1.0" encoding="utf-8"?>
+<file path=ppt/slides/slide6.xml><?xml version="1.0" encoding="utf-8"?>
 <p:sld xmlns:a="http://schemas.openxmlformats.org/drawingml/2006/main" xmlns:r="http://schemas.openxmlformats.org/officeDocument/2006/relationships" xmlns:p="http://schemas.openxmlformats.org/presentationml/2006/main">
   <p:cSld>
     <p:spTree>
@@ -5208,7 +5739,7 @@
 </p:sld>
 </file>
 
-<file path=ppt/slides/slide6.xml><?xml version="1.0" encoding="utf-8"?>
+<file path=ppt/slides/slide7.xml><?xml version="1.0" encoding="utf-8"?>
 <p:sld xmlns:a="http://schemas.openxmlformats.org/drawingml/2006/main" xmlns:r="http://schemas.openxmlformats.org/officeDocument/2006/relationships" xmlns:p="http://schemas.openxmlformats.org/presentationml/2006/main">
   <p:cSld>
     <p:spTree>
@@ -5334,7 +5865,7 @@
 </p:sld>
 </file>
 
-<file path=ppt/slides/slide7.xml><?xml version="1.0" encoding="utf-8"?>
+<file path=ppt/slides/slide8.xml><?xml version="1.0" encoding="utf-8"?>
 <p:sld xmlns:a="http://schemas.openxmlformats.org/drawingml/2006/main" xmlns:r="http://schemas.openxmlformats.org/officeDocument/2006/relationships" xmlns:p="http://schemas.openxmlformats.org/presentationml/2006/main">
   <p:cSld>
     <p:spTree>
@@ -5460,7 +5991,7 @@
 </p:sld>
 </file>
 
-<file path=ppt/slides/slide8.xml><?xml version="1.0" encoding="utf-8"?>
+<file path=ppt/slides/slide9.xml><?xml version="1.0" encoding="utf-8"?>
 <p:sld xmlns:a="http://schemas.openxmlformats.org/drawingml/2006/main" xmlns:r="http://schemas.openxmlformats.org/officeDocument/2006/relationships" xmlns:p="http://schemas.openxmlformats.org/presentationml/2006/main">
   <p:cSld>
     <p:spTree>
@@ -5685,136 +6216,6 @@
     <p:extLst>
       <p:ext uri="{BB962C8B-B14F-4D97-AF65-F5344CB8AC3E}">
         <p14:creationId xmlns:p14="http://schemas.microsoft.com/office/powerpoint/2010/main" val="1328462790"/>
-      </p:ext>
-    </p:extLst>
-  </p:cSld>
-  <p:clrMapOvr>
-    <a:masterClrMapping/>
-  </p:clrMapOvr>
-</p:sld>
-</file>
-
-<file path=ppt/slides/slide9.xml><?xml version="1.0" encoding="utf-8"?>
-<p:sld xmlns:a="http://schemas.openxmlformats.org/drawingml/2006/main" xmlns:r="http://schemas.openxmlformats.org/officeDocument/2006/relationships" xmlns:p="http://schemas.openxmlformats.org/presentationml/2006/main">
-  <p:cSld>
-    <p:spTree>
-      <p:nvGrpSpPr>
-        <p:cNvPr id="1" name="">
-          <a:extLst>
-            <a:ext uri="{FF2B5EF4-FFF2-40B4-BE49-F238E27FC236}">
-              <a16:creationId xmlns:a16="http://schemas.microsoft.com/office/drawing/2014/main" id="{9F1D8A09-B85F-92EB-54E3-667A6F6675B4}"/>
-            </a:ext>
-          </a:extLst>
-        </p:cNvPr>
-        <p:cNvGrpSpPr/>
-        <p:nvPr/>
-      </p:nvGrpSpPr>
-      <p:grpSpPr>
-        <a:xfrm>
-          <a:off x="0" y="0"/>
-          <a:ext cx="0" cy="0"/>
-          <a:chOff x="0" y="0"/>
-          <a:chExt cx="0" cy="0"/>
-        </a:xfrm>
-      </p:grpSpPr>
-      <p:sp>
-        <p:nvSpPr>
-          <p:cNvPr id="2" name="Titel 1">
-            <a:extLst>
-              <a:ext uri="{FF2B5EF4-FFF2-40B4-BE49-F238E27FC236}">
-                <a16:creationId xmlns:a16="http://schemas.microsoft.com/office/drawing/2014/main" id="{48FC1805-E445-7E86-FA1D-BA9D4EB70BC7}"/>
-              </a:ext>
-            </a:extLst>
-          </p:cNvPr>
-          <p:cNvSpPr>
-            <a:spLocks noGrp="1"/>
-          </p:cNvSpPr>
-          <p:nvPr>
-            <p:ph type="title"/>
-          </p:nvPr>
-        </p:nvSpPr>
-        <p:spPr/>
-        <p:txBody>
-          <a:bodyPr/>
-          <a:lstStyle/>
-          <a:p>
-            <a:r>
-              <a:rPr lang="de-DE" dirty="0"/>
-              <a:t>Neue Kategorie</a:t>
-            </a:r>
-            <a:endParaRPr lang="de-CH" dirty="0"/>
-          </a:p>
-        </p:txBody>
-      </p:sp>
-      <p:sp>
-        <p:nvSpPr>
-          <p:cNvPr id="3" name="Inhaltsplatzhalter 2">
-            <a:extLst>
-              <a:ext uri="{FF2B5EF4-FFF2-40B4-BE49-F238E27FC236}">
-                <a16:creationId xmlns:a16="http://schemas.microsoft.com/office/drawing/2014/main" id="{DF2E7619-F740-4A78-5CDE-E1D1ADCEEBBB}"/>
-              </a:ext>
-            </a:extLst>
-          </p:cNvPr>
-          <p:cNvSpPr>
-            <a:spLocks noGrp="1"/>
-          </p:cNvSpPr>
-          <p:nvPr>
-            <p:ph idx="1"/>
-          </p:nvPr>
-        </p:nvSpPr>
-        <p:spPr/>
-        <p:txBody>
-          <a:bodyPr/>
-          <a:lstStyle/>
-          <a:p>
-            <a:endParaRPr lang="de-DE" dirty="0"/>
-          </a:p>
-          <a:p>
-            <a:r>
-              <a:rPr lang="de-CH" dirty="0"/>
-              <a:t>Neue </a:t>
-            </a:r>
-            <a:r>
-              <a:rPr lang="de-CH" dirty="0" err="1"/>
-              <a:t>Vulnerabilities</a:t>
-            </a:r>
-            <a:r>
-              <a:rPr lang="de-CH" dirty="0"/>
-              <a:t> (</a:t>
-            </a:r>
-            <a:r>
-              <a:rPr lang="de-CH" dirty="0" err="1"/>
-              <a:t>Platform</a:t>
-            </a:r>
-            <a:r>
-              <a:rPr lang="de-CH" dirty="0"/>
-              <a:t>):</a:t>
-            </a:r>
-          </a:p>
-          <a:p>
-            <a:r>
-              <a:rPr lang="de-CH" dirty="0"/>
-              <a:t>Maswe_0055</a:t>
-            </a:r>
-          </a:p>
-          <a:p>
-            <a:r>
-              <a:rPr lang="de-CH" dirty="0"/>
-              <a:t>Maswe_0053</a:t>
-            </a:r>
-          </a:p>
-          <a:p>
-            <a:r>
-              <a:rPr lang="de-CH" dirty="0"/>
-              <a:t>Maswe_0067</a:t>
-            </a:r>
-          </a:p>
-        </p:txBody>
-      </p:sp>
-    </p:spTree>
-    <p:extLst>
-      <p:ext uri="{BB962C8B-B14F-4D97-AF65-F5344CB8AC3E}">
-        <p14:creationId xmlns:p14="http://schemas.microsoft.com/office/powerpoint/2010/main" val="2095325492"/>
       </p:ext>
     </p:extLst>
   </p:cSld>

</xml_diff>

<commit_message>
Added first version of powerpoint for meeting 8 to designated folder
</commit_message>
<xml_diff>
--- a/dev_documents/meetings/meeting_07/meeting_07.pptx
+++ b/dev_documents/meetings/meeting_07/meeting_07.pptx
@@ -280,7 +280,7 @@
           <a:p>
             <a:fld id="{9AB30458-6B80-4991-80A5-4D93347D5E6D}" type="datetimeFigureOut">
               <a:rPr lang="de-CH" smtClean="0"/>
-              <a:t>19.12.2025</a:t>
+              <a:t>08.01.2026</a:t>
             </a:fld>
             <a:endParaRPr lang="de-CH"/>
           </a:p>
@@ -480,7 +480,7 @@
           <a:p>
             <a:fld id="{9AB30458-6B80-4991-80A5-4D93347D5E6D}" type="datetimeFigureOut">
               <a:rPr lang="de-CH" smtClean="0"/>
-              <a:t>19.12.2025</a:t>
+              <a:t>08.01.2026</a:t>
             </a:fld>
             <a:endParaRPr lang="de-CH"/>
           </a:p>
@@ -690,7 +690,7 @@
           <a:p>
             <a:fld id="{9AB30458-6B80-4991-80A5-4D93347D5E6D}" type="datetimeFigureOut">
               <a:rPr lang="de-CH" smtClean="0"/>
-              <a:t>19.12.2025</a:t>
+              <a:t>08.01.2026</a:t>
             </a:fld>
             <a:endParaRPr lang="de-CH"/>
           </a:p>
@@ -890,7 +890,7 @@
           <a:p>
             <a:fld id="{9AB30458-6B80-4991-80A5-4D93347D5E6D}" type="datetimeFigureOut">
               <a:rPr lang="de-CH" smtClean="0"/>
-              <a:t>19.12.2025</a:t>
+              <a:t>08.01.2026</a:t>
             </a:fld>
             <a:endParaRPr lang="de-CH"/>
           </a:p>
@@ -1166,7 +1166,7 @@
           <a:p>
             <a:fld id="{9AB30458-6B80-4991-80A5-4D93347D5E6D}" type="datetimeFigureOut">
               <a:rPr lang="de-CH" smtClean="0"/>
-              <a:t>19.12.2025</a:t>
+              <a:t>08.01.2026</a:t>
             </a:fld>
             <a:endParaRPr lang="de-CH"/>
           </a:p>
@@ -1434,7 +1434,7 @@
           <a:p>
             <a:fld id="{9AB30458-6B80-4991-80A5-4D93347D5E6D}" type="datetimeFigureOut">
               <a:rPr lang="de-CH" smtClean="0"/>
-              <a:t>19.12.2025</a:t>
+              <a:t>08.01.2026</a:t>
             </a:fld>
             <a:endParaRPr lang="de-CH"/>
           </a:p>
@@ -1849,7 +1849,7 @@
           <a:p>
             <a:fld id="{9AB30458-6B80-4991-80A5-4D93347D5E6D}" type="datetimeFigureOut">
               <a:rPr lang="de-CH" smtClean="0"/>
-              <a:t>19.12.2025</a:t>
+              <a:t>08.01.2026</a:t>
             </a:fld>
             <a:endParaRPr lang="de-CH"/>
           </a:p>
@@ -1991,7 +1991,7 @@
           <a:p>
             <a:fld id="{9AB30458-6B80-4991-80A5-4D93347D5E6D}" type="datetimeFigureOut">
               <a:rPr lang="de-CH" smtClean="0"/>
-              <a:t>19.12.2025</a:t>
+              <a:t>08.01.2026</a:t>
             </a:fld>
             <a:endParaRPr lang="de-CH"/>
           </a:p>
@@ -2104,7 +2104,7 @@
           <a:p>
             <a:fld id="{9AB30458-6B80-4991-80A5-4D93347D5E6D}" type="datetimeFigureOut">
               <a:rPr lang="de-CH" smtClean="0"/>
-              <a:t>19.12.2025</a:t>
+              <a:t>08.01.2026</a:t>
             </a:fld>
             <a:endParaRPr lang="de-CH"/>
           </a:p>
@@ -2417,7 +2417,7 @@
           <a:p>
             <a:fld id="{9AB30458-6B80-4991-80A5-4D93347D5E6D}" type="datetimeFigureOut">
               <a:rPr lang="de-CH" smtClean="0"/>
-              <a:t>19.12.2025</a:t>
+              <a:t>08.01.2026</a:t>
             </a:fld>
             <a:endParaRPr lang="de-CH"/>
           </a:p>
@@ -2706,7 +2706,7 @@
           <a:p>
             <a:fld id="{9AB30458-6B80-4991-80A5-4D93347D5E6D}" type="datetimeFigureOut">
               <a:rPr lang="de-CH" smtClean="0"/>
-              <a:t>19.12.2025</a:t>
+              <a:t>08.01.2026</a:t>
             </a:fld>
             <a:endParaRPr lang="de-CH"/>
           </a:p>
@@ -2949,7 +2949,7 @@
           <a:p>
             <a:fld id="{9AB30458-6B80-4991-80A5-4D93347D5E6D}" type="datetimeFigureOut">
               <a:rPr lang="de-CH" smtClean="0"/>
-              <a:t>19.12.2025</a:t>
+              <a:t>08.01.2026</a:t>
             </a:fld>
             <a:endParaRPr lang="de-CH"/>
           </a:p>

</xml_diff>